<commit_message>
atulização da apresentação com referências
</commit_message>
<xml_diff>
--- a/Trabalho Prático 1 Estruturas de Representação e Algoritmos Básicos.pptx
+++ b/Trabalho Prático 1 Estruturas de Representação e Algoritmos Básicos.pptx
@@ -15,17 +15,18 @@
     <p:sldId id="263" r:id="rId13"/>
     <p:sldId id="264" r:id="rId14"/>
     <p:sldId id="265" r:id="rId15"/>
+    <p:sldId id="266" r:id="rId16"/>
   </p:sldIdLst>
   <p:sldSz cx="18288000" cy="10287000"/>
   <p:notesSz cx="6858000" cy="9144000"/>
   <p:embeddedFontLst>
     <p:embeddedFont>
       <p:font typeface="Poppins Bold" charset="1" panose="00000800000000000000"/>
-      <p:regular r:id="rId16"/>
+      <p:regular r:id="rId17"/>
     </p:embeddedFont>
     <p:embeddedFont>
       <p:font typeface="Poppins" charset="1" panose="00000500000000000000"/>
-      <p:regular r:id="rId17"/>
+      <p:regular r:id="rId18"/>
     </p:embeddedFont>
   </p:embeddedFontLst>
   <p:defaultTextStyle>
@@ -4328,6 +4329,710 @@
 </p:sld>
 </file>
 
+<file path=ppt/slides/slide11.xml><?xml version="1.0" encoding="utf-8"?>
+<p:sld xmlns:p="http://schemas.openxmlformats.org/presentationml/2006/main" xmlns:a="http://schemas.openxmlformats.org/drawingml/2006/main" xmlns:r="http://schemas.openxmlformats.org/officeDocument/2006/relationships">
+  <p:cSld>
+    <p:spTree>
+      <p:nvGrpSpPr>
+        <p:cNvPr id="1" name=""/>
+        <p:cNvGrpSpPr/>
+        <p:nvPr/>
+      </p:nvGrpSpPr>
+      <p:grpSpPr>
+        <a:xfrm>
+          <a:off x="0" y="0"/>
+          <a:ext cx="0" cy="0"/>
+          <a:chOff x="0" y="0"/>
+          <a:chExt cx="0" cy="0"/>
+        </a:xfrm>
+      </p:grpSpPr>
+      <p:sp>
+        <p:nvSpPr>
+          <p:cNvPr name="TextBox 2" id="2"/>
+          <p:cNvSpPr txBox="true"/>
+          <p:nvPr/>
+        </p:nvSpPr>
+        <p:spPr>
+          <a:xfrm rot="0">
+            <a:off x="1796661" y="3908144"/>
+            <a:ext cx="7874390" cy="1297305"/>
+          </a:xfrm>
+          <a:prstGeom prst="rect">
+            <a:avLst/>
+          </a:prstGeom>
+        </p:spPr>
+        <p:txBody>
+          <a:bodyPr anchor="t" rtlCol="false" tIns="0" lIns="0" bIns="0" rIns="0">
+            <a:spAutoFit/>
+          </a:bodyPr>
+          <a:lstStyle/>
+          <a:p>
+            <a:pPr algn="l" marL="0" indent="0" lvl="0">
+              <a:lnSpc>
+                <a:spcPts val="9075"/>
+              </a:lnSpc>
+            </a:pPr>
+            <a:r>
+              <a:rPr lang="en-US" b="true" sz="9075">
+                <a:solidFill>
+                  <a:srgbClr val="010032"/>
+                </a:solidFill>
+                <a:latin typeface="Poppins Bold"/>
+                <a:ea typeface="Poppins Bold"/>
+                <a:cs typeface="Poppins Bold"/>
+                <a:sym typeface="Poppins Bold"/>
+              </a:rPr>
+              <a:t>REFERÊNCIAS </a:t>
+            </a:r>
+          </a:p>
+        </p:txBody>
+      </p:sp>
+      <p:sp>
+        <p:nvSpPr>
+          <p:cNvPr name="TextBox 3" id="3"/>
+          <p:cNvSpPr txBox="true"/>
+          <p:nvPr/>
+        </p:nvSpPr>
+        <p:spPr>
+          <a:xfrm rot="0">
+            <a:off x="10144266" y="2225707"/>
+            <a:ext cx="6170383" cy="5864234"/>
+          </a:xfrm>
+          <a:prstGeom prst="rect">
+            <a:avLst/>
+          </a:prstGeom>
+        </p:spPr>
+        <p:txBody>
+          <a:bodyPr anchor="t" rtlCol="false" tIns="0" lIns="0" bIns="0" rIns="0">
+            <a:spAutoFit/>
+          </a:bodyPr>
+          <a:lstStyle/>
+          <a:p>
+            <a:pPr algn="l">
+              <a:lnSpc>
+                <a:spcPts val="4612"/>
+              </a:lnSpc>
+            </a:pPr>
+          </a:p>
+          <a:p>
+            <a:pPr algn="l" marL="711290" indent="-355645" lvl="1">
+              <a:lnSpc>
+                <a:spcPts val="4612"/>
+              </a:lnSpc>
+              <a:buFont typeface="Arial"/>
+              <a:buChar char="•"/>
+            </a:pPr>
+            <a:r>
+              <a:rPr lang="en-US" sz="3294">
+                <a:solidFill>
+                  <a:srgbClr val="010032"/>
+                </a:solidFill>
+                <a:latin typeface="Poppins"/>
+                <a:ea typeface="Poppins"/>
+                <a:cs typeface="Poppins"/>
+                <a:sym typeface="Poppins"/>
+              </a:rPr>
+              <a:t>Material de aula</a:t>
+            </a:r>
+          </a:p>
+          <a:p>
+            <a:pPr algn="l" marL="711290" indent="-355645" lvl="1">
+              <a:lnSpc>
+                <a:spcPts val="4612"/>
+              </a:lnSpc>
+              <a:buFont typeface="Arial"/>
+              <a:buChar char="•"/>
+            </a:pPr>
+            <a:r>
+              <a:rPr lang="en-US" sz="3294">
+                <a:solidFill>
+                  <a:srgbClr val="010032"/>
+                </a:solidFill>
+                <a:latin typeface="Poppins"/>
+                <a:ea typeface="Poppins"/>
+                <a:cs typeface="Poppins"/>
+                <a:sym typeface="Poppins"/>
+              </a:rPr>
+              <a:t>Topological Sorting using BFS - Kahn's Algorithm (geeks for geeks)</a:t>
+            </a:r>
+          </a:p>
+          <a:p>
+            <a:pPr algn="l" marL="711290" indent="-355645" lvl="1">
+              <a:lnSpc>
+                <a:spcPts val="4612"/>
+              </a:lnSpc>
+              <a:buFont typeface="Arial"/>
+              <a:buChar char="•"/>
+            </a:pPr>
+            <a:r>
+              <a:rPr lang="en-US" sz="3294">
+                <a:solidFill>
+                  <a:srgbClr val="010032"/>
+                </a:solidFill>
+                <a:latin typeface="Poppins"/>
+                <a:ea typeface="Poppins"/>
+                <a:cs typeface="Poppins"/>
+                <a:sym typeface="Poppins"/>
+              </a:rPr>
+              <a:t>O grupo usou LLMs para fazer correções no código</a:t>
+            </a:r>
+          </a:p>
+          <a:p>
+            <a:pPr algn="l">
+              <a:lnSpc>
+                <a:spcPts val="4612"/>
+              </a:lnSpc>
+            </a:pPr>
+          </a:p>
+          <a:p>
+            <a:pPr algn="l">
+              <a:lnSpc>
+                <a:spcPts val="4612"/>
+              </a:lnSpc>
+            </a:pPr>
+          </a:p>
+          <a:p>
+            <a:pPr algn="l" marL="0" indent="0" lvl="0">
+              <a:lnSpc>
+                <a:spcPts val="4612"/>
+              </a:lnSpc>
+              <a:spcBef>
+                <a:spcPct val="0"/>
+              </a:spcBef>
+            </a:pPr>
+          </a:p>
+        </p:txBody>
+      </p:sp>
+      <p:sp>
+        <p:nvSpPr>
+          <p:cNvPr name="TextBox 4" id="4"/>
+          <p:cNvSpPr txBox="true"/>
+          <p:nvPr/>
+        </p:nvSpPr>
+        <p:spPr>
+          <a:xfrm rot="0">
+            <a:off x="15897978" y="8909050"/>
+            <a:ext cx="1361322" cy="308229"/>
+          </a:xfrm>
+          <a:prstGeom prst="rect">
+            <a:avLst/>
+          </a:prstGeom>
+        </p:spPr>
+        <p:txBody>
+          <a:bodyPr anchor="t" rtlCol="false" tIns="0" lIns="0" bIns="0" rIns="0">
+            <a:spAutoFit/>
+          </a:bodyPr>
+          <a:lstStyle/>
+          <a:p>
+            <a:pPr algn="r" marL="0" indent="0" lvl="0">
+              <a:lnSpc>
+                <a:spcPts val="2436"/>
+              </a:lnSpc>
+            </a:pPr>
+            <a:r>
+              <a:rPr lang="en-US" b="true" sz="1740">
+                <a:solidFill>
+                  <a:srgbClr val="FFFFFF"/>
+                </a:solidFill>
+                <a:latin typeface="Poppins Bold"/>
+                <a:ea typeface="Poppins Bold"/>
+                <a:cs typeface="Poppins Bold"/>
+                <a:sym typeface="Poppins Bold"/>
+              </a:rPr>
+              <a:t>6/6</a:t>
+            </a:r>
+          </a:p>
+        </p:txBody>
+      </p:sp>
+      <p:sp>
+        <p:nvSpPr>
+          <p:cNvPr name="Freeform 5" id="5"/>
+          <p:cNvSpPr/>
+          <p:nvPr/>
+        </p:nvSpPr>
+        <p:spPr>
+          <a:xfrm flipH="false" flipV="false" rot="0">
+            <a:off x="-968836" y="1036371"/>
+            <a:ext cx="1932554" cy="2411924"/>
+          </a:xfrm>
+          <a:custGeom>
+            <a:avLst/>
+            <a:gdLst/>
+            <a:ahLst/>
+            <a:cxnLst/>
+            <a:rect r="r" b="b" t="t" l="l"/>
+            <a:pathLst>
+              <a:path h="2411924" w="1932554">
+                <a:moveTo>
+                  <a:pt x="0" y="0"/>
+                </a:moveTo>
+                <a:lnTo>
+                  <a:pt x="1932554" y="0"/>
+                </a:lnTo>
+                <a:lnTo>
+                  <a:pt x="1932554" y="2411924"/>
+                </a:lnTo>
+                <a:lnTo>
+                  <a:pt x="0" y="2411924"/>
+                </a:lnTo>
+                <a:lnTo>
+                  <a:pt x="0" y="0"/>
+                </a:lnTo>
+                <a:close/>
+              </a:path>
+            </a:pathLst>
+          </a:custGeom>
+          <a:blipFill>
+            <a:blip r:embed="rId2"/>
+            <a:stretch>
+              <a:fillRect l="0" t="0" r="0" b="0"/>
+            </a:stretch>
+          </a:blipFill>
+        </p:spPr>
+      </p:sp>
+      <p:sp>
+        <p:nvSpPr>
+          <p:cNvPr name="Freeform 6" id="6"/>
+          <p:cNvSpPr/>
+          <p:nvPr/>
+        </p:nvSpPr>
+        <p:spPr>
+          <a:xfrm flipH="false" flipV="false" rot="0">
+            <a:off x="16787864" y="6265023"/>
+            <a:ext cx="2996070" cy="3100281"/>
+          </a:xfrm>
+          <a:custGeom>
+            <a:avLst/>
+            <a:gdLst/>
+            <a:ahLst/>
+            <a:cxnLst/>
+            <a:rect r="r" b="b" t="t" l="l"/>
+            <a:pathLst>
+              <a:path h="3100281" w="2996070">
+                <a:moveTo>
+                  <a:pt x="0" y="0"/>
+                </a:moveTo>
+                <a:lnTo>
+                  <a:pt x="2996070" y="0"/>
+                </a:lnTo>
+                <a:lnTo>
+                  <a:pt x="2996070" y="3100280"/>
+                </a:lnTo>
+                <a:lnTo>
+                  <a:pt x="0" y="3100280"/>
+                </a:lnTo>
+                <a:lnTo>
+                  <a:pt x="0" y="0"/>
+                </a:lnTo>
+                <a:close/>
+              </a:path>
+            </a:pathLst>
+          </a:custGeom>
+          <a:blipFill>
+            <a:blip r:embed="rId3"/>
+            <a:stretch>
+              <a:fillRect l="0" t="0" r="0" b="0"/>
+            </a:stretch>
+          </a:blipFill>
+        </p:spPr>
+      </p:sp>
+      <p:grpSp>
+        <p:nvGrpSpPr>
+          <p:cNvPr name="Group 7" id="7"/>
+          <p:cNvGrpSpPr/>
+          <p:nvPr/>
+        </p:nvGrpSpPr>
+        <p:grpSpPr>
+          <a:xfrm rot="0">
+            <a:off x="6036903" y="713794"/>
+            <a:ext cx="6214194" cy="629811"/>
+            <a:chOff x="0" y="0"/>
+            <a:chExt cx="1636660" cy="165876"/>
+          </a:xfrm>
+        </p:grpSpPr>
+        <p:sp>
+          <p:nvSpPr>
+            <p:cNvPr name="Freeform 8" id="8"/>
+            <p:cNvSpPr/>
+            <p:nvPr/>
+          </p:nvSpPr>
+          <p:spPr>
+            <a:xfrm flipH="false" flipV="false" rot="0">
+              <a:off x="0" y="0"/>
+              <a:ext cx="1636660" cy="165876"/>
+            </a:xfrm>
+            <a:custGeom>
+              <a:avLst/>
+              <a:gdLst/>
+              <a:ahLst/>
+              <a:cxnLst/>
+              <a:rect r="r" b="b" t="t" l="l"/>
+              <a:pathLst>
+                <a:path h="165876" w="1636660">
+                  <a:moveTo>
+                    <a:pt x="68521" y="0"/>
+                  </a:moveTo>
+                  <a:lnTo>
+                    <a:pt x="1568139" y="0"/>
+                  </a:lnTo>
+                  <a:cubicBezTo>
+                    <a:pt x="1586312" y="0"/>
+                    <a:pt x="1603740" y="7219"/>
+                    <a:pt x="1616591" y="20069"/>
+                  </a:cubicBezTo>
+                  <a:cubicBezTo>
+                    <a:pt x="1629441" y="32920"/>
+                    <a:pt x="1636660" y="50348"/>
+                    <a:pt x="1636660" y="68521"/>
+                  </a:cubicBezTo>
+                  <a:lnTo>
+                    <a:pt x="1636660" y="97355"/>
+                  </a:lnTo>
+                  <a:cubicBezTo>
+                    <a:pt x="1636660" y="115528"/>
+                    <a:pt x="1629441" y="132957"/>
+                    <a:pt x="1616591" y="145807"/>
+                  </a:cubicBezTo>
+                  <a:cubicBezTo>
+                    <a:pt x="1603740" y="158657"/>
+                    <a:pt x="1586312" y="165876"/>
+                    <a:pt x="1568139" y="165876"/>
+                  </a:cubicBezTo>
+                  <a:lnTo>
+                    <a:pt x="68521" y="165876"/>
+                  </a:lnTo>
+                  <a:cubicBezTo>
+                    <a:pt x="50348" y="165876"/>
+                    <a:pt x="32920" y="158657"/>
+                    <a:pt x="20069" y="145807"/>
+                  </a:cubicBezTo>
+                  <a:cubicBezTo>
+                    <a:pt x="7219" y="132957"/>
+                    <a:pt x="0" y="115528"/>
+                    <a:pt x="0" y="97355"/>
+                  </a:cubicBezTo>
+                  <a:lnTo>
+                    <a:pt x="0" y="68521"/>
+                  </a:lnTo>
+                  <a:cubicBezTo>
+                    <a:pt x="0" y="50348"/>
+                    <a:pt x="7219" y="32920"/>
+                    <a:pt x="20069" y="20069"/>
+                  </a:cubicBezTo>
+                  <a:cubicBezTo>
+                    <a:pt x="32920" y="7219"/>
+                    <a:pt x="50348" y="0"/>
+                    <a:pt x="68521" y="0"/>
+                  </a:cubicBezTo>
+                  <a:close/>
+                </a:path>
+              </a:pathLst>
+            </a:custGeom>
+            <a:gradFill rotWithShape="true">
+              <a:gsLst>
+                <a:gs pos="0">
+                  <a:srgbClr val="7ED7EF">
+                    <a:alpha val="100000"/>
+                  </a:srgbClr>
+                </a:gs>
+                <a:gs pos="100000">
+                  <a:srgbClr val="B17FD6">
+                    <a:alpha val="100000"/>
+                  </a:srgbClr>
+                </a:gs>
+              </a:gsLst>
+              <a:lin ang="0"/>
+            </a:gradFill>
+            <a:ln cap="rnd">
+              <a:noFill/>
+              <a:prstDash val="solid"/>
+              <a:round/>
+            </a:ln>
+          </p:spPr>
+        </p:sp>
+        <p:sp>
+          <p:nvSpPr>
+            <p:cNvPr name="TextBox 9" id="9"/>
+            <p:cNvSpPr txBox="true"/>
+            <p:nvPr/>
+          </p:nvSpPr>
+          <p:spPr>
+            <a:xfrm>
+              <a:off x="0" y="-66675"/>
+              <a:ext cx="1636660" cy="232551"/>
+            </a:xfrm>
+            <a:prstGeom prst="rect">
+              <a:avLst/>
+            </a:prstGeom>
+          </p:spPr>
+          <p:txBody>
+            <a:bodyPr anchor="ctr" rtlCol="false" tIns="50800" lIns="50800" bIns="50800" rIns="50800"/>
+            <a:lstStyle/>
+            <a:p>
+              <a:pPr algn="ctr" marL="0" indent="0" lvl="0">
+                <a:lnSpc>
+                  <a:spcPts val="2800"/>
+                </a:lnSpc>
+              </a:pPr>
+            </a:p>
+          </p:txBody>
+        </p:sp>
+      </p:grpSp>
+      <p:sp>
+        <p:nvSpPr>
+          <p:cNvPr name="TextBox 10" id="10"/>
+          <p:cNvSpPr txBox="true"/>
+          <p:nvPr/>
+        </p:nvSpPr>
+        <p:spPr>
+          <a:xfrm rot="0">
+            <a:off x="8624026" y="830263"/>
+            <a:ext cx="1771539" cy="332097"/>
+          </a:xfrm>
+          <a:prstGeom prst="rect">
+            <a:avLst/>
+          </a:prstGeom>
+        </p:spPr>
+        <p:txBody>
+          <a:bodyPr anchor="t" rtlCol="false" tIns="0" lIns="0" bIns="0" rIns="0">
+            <a:spAutoFit/>
+          </a:bodyPr>
+          <a:lstStyle/>
+          <a:p>
+            <a:pPr algn="ctr" marL="0" indent="0" lvl="0">
+              <a:lnSpc>
+                <a:spcPts val="2695"/>
+              </a:lnSpc>
+            </a:pPr>
+            <a:r>
+              <a:rPr lang="en-US" sz="1925">
+                <a:solidFill>
+                  <a:srgbClr val="FFFFFF"/>
+                </a:solidFill>
+                <a:latin typeface="Poppins"/>
+                <a:ea typeface="Poppins"/>
+                <a:cs typeface="Poppins"/>
+                <a:sym typeface="Poppins"/>
+              </a:rPr>
+              <a:t>ARQU</a:t>
+            </a:r>
+            <a:r>
+              <a:rPr lang="en-US" sz="1925">
+                <a:solidFill>
+                  <a:srgbClr val="FFFFFF"/>
+                </a:solidFill>
+                <a:latin typeface="Poppins"/>
+                <a:ea typeface="Poppins"/>
+                <a:cs typeface="Poppins"/>
+                <a:sym typeface="Poppins"/>
+              </a:rPr>
+              <a:t>ITETURA </a:t>
+            </a:r>
+          </a:p>
+        </p:txBody>
+      </p:sp>
+      <p:sp>
+        <p:nvSpPr>
+          <p:cNvPr name="TextBox 11" id="11"/>
+          <p:cNvSpPr txBox="true"/>
+          <p:nvPr/>
+        </p:nvSpPr>
+        <p:spPr>
+          <a:xfrm rot="0">
+            <a:off x="6212070" y="820738"/>
+            <a:ext cx="2074084" cy="358811"/>
+          </a:xfrm>
+          <a:prstGeom prst="rect">
+            <a:avLst/>
+          </a:prstGeom>
+        </p:spPr>
+        <p:txBody>
+          <a:bodyPr anchor="t" rtlCol="false" tIns="0" lIns="0" bIns="0" rIns="0">
+            <a:spAutoFit/>
+          </a:bodyPr>
+          <a:lstStyle/>
+          <a:p>
+            <a:pPr algn="ctr" marL="0" indent="0" lvl="0">
+              <a:lnSpc>
+                <a:spcPts val="2798"/>
+              </a:lnSpc>
+            </a:pPr>
+            <a:r>
+              <a:rPr lang="en-US" sz="1998">
+                <a:solidFill>
+                  <a:srgbClr val="FFFFFF"/>
+                </a:solidFill>
+                <a:latin typeface="Poppins"/>
+                <a:ea typeface="Poppins"/>
+                <a:cs typeface="Poppins"/>
+                <a:sym typeface="Poppins"/>
+              </a:rPr>
+              <a:t>INT</a:t>
+            </a:r>
+            <a:r>
+              <a:rPr lang="en-US" sz="1998">
+                <a:solidFill>
+                  <a:srgbClr val="FFFFFF"/>
+                </a:solidFill>
+                <a:latin typeface="Poppins"/>
+                <a:ea typeface="Poppins"/>
+                <a:cs typeface="Poppins"/>
+                <a:sym typeface="Poppins"/>
+              </a:rPr>
+              <a:t>RODUÇÃO </a:t>
+            </a:r>
+          </a:p>
+        </p:txBody>
+      </p:sp>
+      <p:sp>
+        <p:nvSpPr>
+          <p:cNvPr name="TextBox 12" id="12"/>
+          <p:cNvSpPr txBox="true"/>
+          <p:nvPr/>
+        </p:nvSpPr>
+        <p:spPr>
+          <a:xfrm rot="0">
+            <a:off x="10497847" y="820738"/>
+            <a:ext cx="1724675" cy="358811"/>
+          </a:xfrm>
+          <a:prstGeom prst="rect">
+            <a:avLst/>
+          </a:prstGeom>
+        </p:spPr>
+        <p:txBody>
+          <a:bodyPr anchor="t" rtlCol="false" tIns="0" lIns="0" bIns="0" rIns="0">
+            <a:spAutoFit/>
+          </a:bodyPr>
+          <a:lstStyle/>
+          <a:p>
+            <a:pPr algn="ctr" marL="0" indent="0" lvl="0">
+              <a:lnSpc>
+                <a:spcPts val="2798"/>
+              </a:lnSpc>
+            </a:pPr>
+            <a:r>
+              <a:rPr lang="en-US" b="true" sz="1998">
+                <a:solidFill>
+                  <a:srgbClr val="010032"/>
+                </a:solidFill>
+                <a:latin typeface="Poppins Bold"/>
+                <a:ea typeface="Poppins Bold"/>
+                <a:cs typeface="Poppins Bold"/>
+                <a:sym typeface="Poppins Bold"/>
+              </a:rPr>
+              <a:t>CONCLUSÃ</a:t>
+            </a:r>
+            <a:r>
+              <a:rPr lang="en-US" b="true" sz="1998">
+                <a:solidFill>
+                  <a:srgbClr val="010032"/>
+                </a:solidFill>
+                <a:latin typeface="Poppins Bold"/>
+                <a:ea typeface="Poppins Bold"/>
+                <a:cs typeface="Poppins Bold"/>
+                <a:sym typeface="Poppins Bold"/>
+              </a:rPr>
+              <a:t>O</a:t>
+            </a:r>
+          </a:p>
+        </p:txBody>
+      </p:sp>
+      <p:sp>
+        <p:nvSpPr>
+          <p:cNvPr name="TextBox 13" id="13"/>
+          <p:cNvSpPr txBox="true"/>
+          <p:nvPr/>
+        </p:nvSpPr>
+        <p:spPr>
+          <a:xfrm rot="0">
+            <a:off x="963718" y="8788995"/>
+            <a:ext cx="5248352" cy="358811"/>
+          </a:xfrm>
+          <a:prstGeom prst="rect">
+            <a:avLst/>
+          </a:prstGeom>
+        </p:spPr>
+        <p:txBody>
+          <a:bodyPr anchor="t" rtlCol="false" tIns="0" lIns="0" bIns="0" rIns="0">
+            <a:spAutoFit/>
+          </a:bodyPr>
+          <a:lstStyle/>
+          <a:p>
+            <a:pPr algn="just">
+              <a:lnSpc>
+                <a:spcPts val="2798"/>
+              </a:lnSpc>
+              <a:spcBef>
+                <a:spcPct val="0"/>
+              </a:spcBef>
+            </a:pPr>
+            <a:r>
+              <a:rPr lang="en-US" sz="1998">
+                <a:solidFill>
+                  <a:srgbClr val="000000"/>
+                </a:solidFill>
+                <a:latin typeface="Poppins"/>
+                <a:ea typeface="Poppins"/>
+                <a:cs typeface="Poppins"/>
+                <a:sym typeface="Poppins"/>
+              </a:rPr>
+              <a:t>O TRABALHO PODE SER ENCONTRADO EM: </a:t>
+            </a:r>
+          </a:p>
+        </p:txBody>
+      </p:sp>
+      <p:sp>
+        <p:nvSpPr>
+          <p:cNvPr name="TextBox 14" id="14"/>
+          <p:cNvSpPr txBox="true"/>
+          <p:nvPr/>
+        </p:nvSpPr>
+        <p:spPr>
+          <a:xfrm rot="0">
+            <a:off x="6150652" y="8788995"/>
+            <a:ext cx="6100445" cy="358811"/>
+          </a:xfrm>
+          <a:prstGeom prst="rect">
+            <a:avLst/>
+          </a:prstGeom>
+        </p:spPr>
+        <p:txBody>
+          <a:bodyPr anchor="t" rtlCol="false" tIns="0" lIns="0" bIns="0" rIns="0">
+            <a:spAutoFit/>
+          </a:bodyPr>
+          <a:lstStyle/>
+          <a:p>
+            <a:pPr algn="l">
+              <a:lnSpc>
+                <a:spcPts val="2798"/>
+              </a:lnSpc>
+              <a:spcBef>
+                <a:spcPct val="0"/>
+              </a:spcBef>
+            </a:pPr>
+            <a:r>
+              <a:rPr lang="en-US" sz="1998" u="sng">
+                <a:solidFill>
+                  <a:srgbClr val="000000"/>
+                </a:solidFill>
+                <a:latin typeface="Poppins"/>
+                <a:ea typeface="Poppins"/>
+                <a:cs typeface="Poppins"/>
+                <a:sym typeface="Poppins"/>
+              </a:rPr>
+              <a:t>HTTPS://GITHUB.COM/L-FFS/GRAPH-TOOLBOX.GIT</a:t>
+            </a:r>
+          </a:p>
+        </p:txBody>
+      </p:sp>
+    </p:spTree>
+  </p:cSld>
+  <p:clrMapOvr>
+    <a:masterClrMapping/>
+  </p:clrMapOvr>
+</p:sld>
+</file>
+
 <file path=ppt/slides/slide2.xml><?xml version="1.0" encoding="utf-8"?>
 <p:sld xmlns:p="http://schemas.openxmlformats.org/presentationml/2006/main" xmlns:a="http://schemas.openxmlformats.org/drawingml/2006/main" xmlns:r="http://schemas.openxmlformats.org/officeDocument/2006/relationships">
   <p:cSld>

</xml_diff>